<commit_message>
Apply company CI style and remove English slide labels
</commit_message>
<xml_diff>
--- a/receivables-tax-considerations.pptx
+++ b/receivables-tax-considerations.pptx
@@ -3365,6 +3365,116 @@
           </a:p>
         </p:txBody>
       </p:sp>
+      <p:sp>
+        <p:nvSpPr>
+          <p:cNvPr id="9" name="Rectangle 8"/>
+          <p:cNvSpPr/>
+          <p:nvPr/>
+        </p:nvSpPr>
+        <p:spPr>
+          <a:xfrm>
+            <a:off x="566928" y="384048"/>
+            <a:ext cx="10744200" cy="22860"/>
+          </a:xfrm>
+          <a:prstGeom prst="rect">
+            <a:avLst/>
+          </a:prstGeom>
+          <a:solidFill>
+            <a:srgbClr val="0B8F55"/>
+          </a:solidFill>
+          <a:ln>
+            <a:noFill/>
+          </a:ln>
+        </p:spPr>
+        <p:style>
+          <a:lnRef idx="1">
+            <a:schemeClr val="accent1"/>
+          </a:lnRef>
+          <a:fillRef idx="3">
+            <a:schemeClr val="accent1"/>
+          </a:fillRef>
+          <a:effectRef idx="2">
+            <a:schemeClr val="accent1"/>
+          </a:effectRef>
+          <a:fontRef idx="minor">
+            <a:schemeClr val="lt1"/>
+          </a:fontRef>
+        </p:style>
+        <p:txBody>
+          <a:bodyPr rtlCol="0" anchor="ctr"/>
+          <a:lstStyle/>
+          <a:p>
+            <a:pPr algn="ctr"/>
+          </a:p>
+        </p:txBody>
+      </p:sp>
+      <p:sp>
+        <p:nvSpPr>
+          <p:cNvPr id="10" name="Rounded Rectangle 9"/>
+          <p:cNvSpPr/>
+          <p:nvPr/>
+        </p:nvSpPr>
+        <p:spPr>
+          <a:xfrm>
+            <a:off x="9308592" y="164592"/>
+            <a:ext cx="2331720" cy="384048"/>
+          </a:xfrm>
+          <a:prstGeom prst="roundRect">
+            <a:avLst/>
+          </a:prstGeom>
+          <a:solidFill>
+            <a:srgbClr val="123D2A"/>
+          </a:solidFill>
+          <a:ln>
+            <a:noFill/>
+          </a:ln>
+        </p:spPr>
+        <p:style>
+          <a:lnRef idx="1">
+            <a:schemeClr val="accent1"/>
+          </a:lnRef>
+          <a:fillRef idx="3">
+            <a:schemeClr val="accent1"/>
+          </a:fillRef>
+          <a:effectRef idx="2">
+            <a:schemeClr val="accent1"/>
+          </a:effectRef>
+          <a:fontRef idx="minor">
+            <a:schemeClr val="lt1"/>
+          </a:fontRef>
+        </p:style>
+        <p:txBody>
+          <a:bodyPr rtlCol="0" anchor="ctr"/>
+          <a:lstStyle/>
+          <a:p>
+            <a:pPr algn="ctr"/>
+          </a:p>
+        </p:txBody>
+      </p:sp>
+      <p:pic>
+        <p:nvPicPr>
+          <p:cNvPr id="11" name="Picture 10" descr="sangah-logo.png"/>
+          <p:cNvPicPr>
+            <a:picLocks noChangeAspect="1"/>
+          </p:cNvPicPr>
+          <p:nvPr/>
+        </p:nvPicPr>
+        <p:blipFill>
+          <a:blip r:embed="rId2"/>
+          <a:stretch>
+            <a:fillRect/>
+          </a:stretch>
+        </p:blipFill>
+        <p:spPr>
+          <a:xfrm>
+            <a:off x="9436608" y="256032"/>
+            <a:ext cx="2057400" cy="292608"/>
+          </a:xfrm>
+          <a:prstGeom prst="rect">
+            <a:avLst/>
+          </a:prstGeom>
+        </p:spPr>
+      </p:pic>
     </p:spTree>
   </p:cSld>
   <p:clrMapOvr>
@@ -3938,6 +4048,116 @@
           </a:p>
         </p:txBody>
       </p:sp>
+      <p:sp>
+        <p:nvSpPr>
+          <p:cNvPr id="8" name="Rectangle 7"/>
+          <p:cNvSpPr/>
+          <p:nvPr/>
+        </p:nvSpPr>
+        <p:spPr>
+          <a:xfrm>
+            <a:off x="566928" y="384048"/>
+            <a:ext cx="10744200" cy="22860"/>
+          </a:xfrm>
+          <a:prstGeom prst="rect">
+            <a:avLst/>
+          </a:prstGeom>
+          <a:solidFill>
+            <a:srgbClr val="0B8F55"/>
+          </a:solidFill>
+          <a:ln>
+            <a:noFill/>
+          </a:ln>
+        </p:spPr>
+        <p:style>
+          <a:lnRef idx="1">
+            <a:schemeClr val="accent1"/>
+          </a:lnRef>
+          <a:fillRef idx="3">
+            <a:schemeClr val="accent1"/>
+          </a:fillRef>
+          <a:effectRef idx="2">
+            <a:schemeClr val="accent1"/>
+          </a:effectRef>
+          <a:fontRef idx="minor">
+            <a:schemeClr val="lt1"/>
+          </a:fontRef>
+        </p:style>
+        <p:txBody>
+          <a:bodyPr rtlCol="0" anchor="ctr"/>
+          <a:lstStyle/>
+          <a:p>
+            <a:pPr algn="ctr"/>
+          </a:p>
+        </p:txBody>
+      </p:sp>
+      <p:sp>
+        <p:nvSpPr>
+          <p:cNvPr id="9" name="Rounded Rectangle 8"/>
+          <p:cNvSpPr/>
+          <p:nvPr/>
+        </p:nvSpPr>
+        <p:spPr>
+          <a:xfrm>
+            <a:off x="9308592" y="164592"/>
+            <a:ext cx="2331720" cy="384048"/>
+          </a:xfrm>
+          <a:prstGeom prst="roundRect">
+            <a:avLst/>
+          </a:prstGeom>
+          <a:solidFill>
+            <a:srgbClr val="123D2A"/>
+          </a:solidFill>
+          <a:ln>
+            <a:noFill/>
+          </a:ln>
+        </p:spPr>
+        <p:style>
+          <a:lnRef idx="1">
+            <a:schemeClr val="accent1"/>
+          </a:lnRef>
+          <a:fillRef idx="3">
+            <a:schemeClr val="accent1"/>
+          </a:fillRef>
+          <a:effectRef idx="2">
+            <a:schemeClr val="accent1"/>
+          </a:effectRef>
+          <a:fontRef idx="minor">
+            <a:schemeClr val="lt1"/>
+          </a:fontRef>
+        </p:style>
+        <p:txBody>
+          <a:bodyPr rtlCol="0" anchor="ctr"/>
+          <a:lstStyle/>
+          <a:p>
+            <a:pPr algn="ctr"/>
+          </a:p>
+        </p:txBody>
+      </p:sp>
+      <p:pic>
+        <p:nvPicPr>
+          <p:cNvPr id="10" name="Picture 9" descr="sangah-logo.png"/>
+          <p:cNvPicPr>
+            <a:picLocks noChangeAspect="1"/>
+          </p:cNvPicPr>
+          <p:nvPr/>
+        </p:nvPicPr>
+        <p:blipFill>
+          <a:blip r:embed="rId2"/>
+          <a:stretch>
+            <a:fillRect/>
+          </a:stretch>
+        </p:blipFill>
+        <p:spPr>
+          <a:xfrm>
+            <a:off x="9436608" y="256032"/>
+            <a:ext cx="2057400" cy="292608"/>
+          </a:xfrm>
+          <a:prstGeom prst="rect">
+            <a:avLst/>
+          </a:prstGeom>
+        </p:spPr>
+      </p:pic>
     </p:spTree>
   </p:cSld>
   <p:clrMapOvr>
@@ -4452,6 +4672,116 @@
           </a:p>
         </p:txBody>
       </p:sp>
+      <p:sp>
+        <p:nvSpPr>
+          <p:cNvPr id="13" name="Rectangle 12"/>
+          <p:cNvSpPr/>
+          <p:nvPr/>
+        </p:nvSpPr>
+        <p:spPr>
+          <a:xfrm>
+            <a:off x="566928" y="384048"/>
+            <a:ext cx="10744200" cy="22860"/>
+          </a:xfrm>
+          <a:prstGeom prst="rect">
+            <a:avLst/>
+          </a:prstGeom>
+          <a:solidFill>
+            <a:srgbClr val="0B8F55"/>
+          </a:solidFill>
+          <a:ln>
+            <a:noFill/>
+          </a:ln>
+        </p:spPr>
+        <p:style>
+          <a:lnRef idx="1">
+            <a:schemeClr val="accent1"/>
+          </a:lnRef>
+          <a:fillRef idx="3">
+            <a:schemeClr val="accent1"/>
+          </a:fillRef>
+          <a:effectRef idx="2">
+            <a:schemeClr val="accent1"/>
+          </a:effectRef>
+          <a:fontRef idx="minor">
+            <a:schemeClr val="lt1"/>
+          </a:fontRef>
+        </p:style>
+        <p:txBody>
+          <a:bodyPr rtlCol="0" anchor="ctr"/>
+          <a:lstStyle/>
+          <a:p>
+            <a:pPr algn="ctr"/>
+          </a:p>
+        </p:txBody>
+      </p:sp>
+      <p:sp>
+        <p:nvSpPr>
+          <p:cNvPr id="14" name="Rounded Rectangle 13"/>
+          <p:cNvSpPr/>
+          <p:nvPr/>
+        </p:nvSpPr>
+        <p:spPr>
+          <a:xfrm>
+            <a:off x="9308592" y="164592"/>
+            <a:ext cx="2331720" cy="384048"/>
+          </a:xfrm>
+          <a:prstGeom prst="roundRect">
+            <a:avLst/>
+          </a:prstGeom>
+          <a:solidFill>
+            <a:srgbClr val="123D2A"/>
+          </a:solidFill>
+          <a:ln>
+            <a:noFill/>
+          </a:ln>
+        </p:spPr>
+        <p:style>
+          <a:lnRef idx="1">
+            <a:schemeClr val="accent1"/>
+          </a:lnRef>
+          <a:fillRef idx="3">
+            <a:schemeClr val="accent1"/>
+          </a:fillRef>
+          <a:effectRef idx="2">
+            <a:schemeClr val="accent1"/>
+          </a:effectRef>
+          <a:fontRef idx="minor">
+            <a:schemeClr val="lt1"/>
+          </a:fontRef>
+        </p:style>
+        <p:txBody>
+          <a:bodyPr rtlCol="0" anchor="ctr"/>
+          <a:lstStyle/>
+          <a:p>
+            <a:pPr algn="ctr"/>
+          </a:p>
+        </p:txBody>
+      </p:sp>
+      <p:pic>
+        <p:nvPicPr>
+          <p:cNvPr id="15" name="Picture 14" descr="sangah-logo.png"/>
+          <p:cNvPicPr>
+            <a:picLocks noChangeAspect="1"/>
+          </p:cNvPicPr>
+          <p:nvPr/>
+        </p:nvPicPr>
+        <p:blipFill>
+          <a:blip r:embed="rId2"/>
+          <a:stretch>
+            <a:fillRect/>
+          </a:stretch>
+        </p:blipFill>
+        <p:spPr>
+          <a:xfrm>
+            <a:off x="9436608" y="256032"/>
+            <a:ext cx="2057400" cy="292608"/>
+          </a:xfrm>
+          <a:prstGeom prst="rect">
+            <a:avLst/>
+          </a:prstGeom>
+        </p:spPr>
+      </p:pic>
     </p:spTree>
   </p:cSld>
   <p:clrMapOvr>
@@ -4825,6 +5155,116 @@
           </a:p>
         </p:txBody>
       </p:sp>
+      <p:sp>
+        <p:nvSpPr>
+          <p:cNvPr id="10" name="Rectangle 9"/>
+          <p:cNvSpPr/>
+          <p:nvPr/>
+        </p:nvSpPr>
+        <p:spPr>
+          <a:xfrm>
+            <a:off x="566928" y="384048"/>
+            <a:ext cx="10744200" cy="22860"/>
+          </a:xfrm>
+          <a:prstGeom prst="rect">
+            <a:avLst/>
+          </a:prstGeom>
+          <a:solidFill>
+            <a:srgbClr val="0B8F55"/>
+          </a:solidFill>
+          <a:ln>
+            <a:noFill/>
+          </a:ln>
+        </p:spPr>
+        <p:style>
+          <a:lnRef idx="1">
+            <a:schemeClr val="accent1"/>
+          </a:lnRef>
+          <a:fillRef idx="3">
+            <a:schemeClr val="accent1"/>
+          </a:fillRef>
+          <a:effectRef idx="2">
+            <a:schemeClr val="accent1"/>
+          </a:effectRef>
+          <a:fontRef idx="minor">
+            <a:schemeClr val="lt1"/>
+          </a:fontRef>
+        </p:style>
+        <p:txBody>
+          <a:bodyPr rtlCol="0" anchor="ctr"/>
+          <a:lstStyle/>
+          <a:p>
+            <a:pPr algn="ctr"/>
+          </a:p>
+        </p:txBody>
+      </p:sp>
+      <p:sp>
+        <p:nvSpPr>
+          <p:cNvPr id="11" name="Rounded Rectangle 10"/>
+          <p:cNvSpPr/>
+          <p:nvPr/>
+        </p:nvSpPr>
+        <p:spPr>
+          <a:xfrm>
+            <a:off x="9308592" y="164592"/>
+            <a:ext cx="2331720" cy="384048"/>
+          </a:xfrm>
+          <a:prstGeom prst="roundRect">
+            <a:avLst/>
+          </a:prstGeom>
+          <a:solidFill>
+            <a:srgbClr val="123D2A"/>
+          </a:solidFill>
+          <a:ln>
+            <a:noFill/>
+          </a:ln>
+        </p:spPr>
+        <p:style>
+          <a:lnRef idx="1">
+            <a:schemeClr val="accent1"/>
+          </a:lnRef>
+          <a:fillRef idx="3">
+            <a:schemeClr val="accent1"/>
+          </a:fillRef>
+          <a:effectRef idx="2">
+            <a:schemeClr val="accent1"/>
+          </a:effectRef>
+          <a:fontRef idx="minor">
+            <a:schemeClr val="lt1"/>
+          </a:fontRef>
+        </p:style>
+        <p:txBody>
+          <a:bodyPr rtlCol="0" anchor="ctr"/>
+          <a:lstStyle/>
+          <a:p>
+            <a:pPr algn="ctr"/>
+          </a:p>
+        </p:txBody>
+      </p:sp>
+      <p:pic>
+        <p:nvPicPr>
+          <p:cNvPr id="12" name="Picture 11" descr="sangah-logo.png"/>
+          <p:cNvPicPr>
+            <a:picLocks noChangeAspect="1"/>
+          </p:cNvPicPr>
+          <p:nvPr/>
+        </p:nvPicPr>
+        <p:blipFill>
+          <a:blip r:embed="rId2"/>
+          <a:stretch>
+            <a:fillRect/>
+          </a:stretch>
+        </p:blipFill>
+        <p:spPr>
+          <a:xfrm>
+            <a:off x="9436608" y="256032"/>
+            <a:ext cx="2057400" cy="292608"/>
+          </a:xfrm>
+          <a:prstGeom prst="rect">
+            <a:avLst/>
+          </a:prstGeom>
+        </p:spPr>
+      </p:pic>
     </p:spTree>
   </p:cSld>
   <p:clrMapOvr>
@@ -5499,6 +5939,116 @@
           </a:p>
         </p:txBody>
       </p:sp>
+      <p:sp>
+        <p:nvSpPr>
+          <p:cNvPr id="19" name="Rectangle 18"/>
+          <p:cNvSpPr/>
+          <p:nvPr/>
+        </p:nvSpPr>
+        <p:spPr>
+          <a:xfrm>
+            <a:off x="566928" y="384048"/>
+            <a:ext cx="10744200" cy="22860"/>
+          </a:xfrm>
+          <a:prstGeom prst="rect">
+            <a:avLst/>
+          </a:prstGeom>
+          <a:solidFill>
+            <a:srgbClr val="0B8F55"/>
+          </a:solidFill>
+          <a:ln>
+            <a:noFill/>
+          </a:ln>
+        </p:spPr>
+        <p:style>
+          <a:lnRef idx="1">
+            <a:schemeClr val="accent1"/>
+          </a:lnRef>
+          <a:fillRef idx="3">
+            <a:schemeClr val="accent1"/>
+          </a:fillRef>
+          <a:effectRef idx="2">
+            <a:schemeClr val="accent1"/>
+          </a:effectRef>
+          <a:fontRef idx="minor">
+            <a:schemeClr val="lt1"/>
+          </a:fontRef>
+        </p:style>
+        <p:txBody>
+          <a:bodyPr rtlCol="0" anchor="ctr"/>
+          <a:lstStyle/>
+          <a:p>
+            <a:pPr algn="ctr"/>
+          </a:p>
+        </p:txBody>
+      </p:sp>
+      <p:sp>
+        <p:nvSpPr>
+          <p:cNvPr id="20" name="Rounded Rectangle 19"/>
+          <p:cNvSpPr/>
+          <p:nvPr/>
+        </p:nvSpPr>
+        <p:spPr>
+          <a:xfrm>
+            <a:off x="9308592" y="164592"/>
+            <a:ext cx="2331720" cy="384048"/>
+          </a:xfrm>
+          <a:prstGeom prst="roundRect">
+            <a:avLst/>
+          </a:prstGeom>
+          <a:solidFill>
+            <a:srgbClr val="123D2A"/>
+          </a:solidFill>
+          <a:ln>
+            <a:noFill/>
+          </a:ln>
+        </p:spPr>
+        <p:style>
+          <a:lnRef idx="1">
+            <a:schemeClr val="accent1"/>
+          </a:lnRef>
+          <a:fillRef idx="3">
+            <a:schemeClr val="accent1"/>
+          </a:fillRef>
+          <a:effectRef idx="2">
+            <a:schemeClr val="accent1"/>
+          </a:effectRef>
+          <a:fontRef idx="minor">
+            <a:schemeClr val="lt1"/>
+          </a:fontRef>
+        </p:style>
+        <p:txBody>
+          <a:bodyPr rtlCol="0" anchor="ctr"/>
+          <a:lstStyle/>
+          <a:p>
+            <a:pPr algn="ctr"/>
+          </a:p>
+        </p:txBody>
+      </p:sp>
+      <p:pic>
+        <p:nvPicPr>
+          <p:cNvPr id="21" name="Picture 20" descr="sangah-logo.png"/>
+          <p:cNvPicPr>
+            <a:picLocks noChangeAspect="1"/>
+          </p:cNvPicPr>
+          <p:nvPr/>
+        </p:nvPicPr>
+        <p:blipFill>
+          <a:blip r:embed="rId2"/>
+          <a:stretch>
+            <a:fillRect/>
+          </a:stretch>
+        </p:blipFill>
+        <p:spPr>
+          <a:xfrm>
+            <a:off x="9436608" y="256032"/>
+            <a:ext cx="2057400" cy="292608"/>
+          </a:xfrm>
+          <a:prstGeom prst="rect">
+            <a:avLst/>
+          </a:prstGeom>
+        </p:spPr>
+      </p:pic>
     </p:spTree>
   </p:cSld>
   <p:clrMapOvr>
@@ -5987,6 +6537,116 @@
           </a:p>
         </p:txBody>
       </p:sp>
+      <p:sp>
+        <p:nvSpPr>
+          <p:cNvPr id="13" name="Rectangle 12"/>
+          <p:cNvSpPr/>
+          <p:nvPr/>
+        </p:nvSpPr>
+        <p:spPr>
+          <a:xfrm>
+            <a:off x="566928" y="384048"/>
+            <a:ext cx="10744200" cy="22860"/>
+          </a:xfrm>
+          <a:prstGeom prst="rect">
+            <a:avLst/>
+          </a:prstGeom>
+          <a:solidFill>
+            <a:srgbClr val="0B8F55"/>
+          </a:solidFill>
+          <a:ln>
+            <a:noFill/>
+          </a:ln>
+        </p:spPr>
+        <p:style>
+          <a:lnRef idx="1">
+            <a:schemeClr val="accent1"/>
+          </a:lnRef>
+          <a:fillRef idx="3">
+            <a:schemeClr val="accent1"/>
+          </a:fillRef>
+          <a:effectRef idx="2">
+            <a:schemeClr val="accent1"/>
+          </a:effectRef>
+          <a:fontRef idx="minor">
+            <a:schemeClr val="lt1"/>
+          </a:fontRef>
+        </p:style>
+        <p:txBody>
+          <a:bodyPr rtlCol="0" anchor="ctr"/>
+          <a:lstStyle/>
+          <a:p>
+            <a:pPr algn="ctr"/>
+          </a:p>
+        </p:txBody>
+      </p:sp>
+      <p:sp>
+        <p:nvSpPr>
+          <p:cNvPr id="14" name="Rounded Rectangle 13"/>
+          <p:cNvSpPr/>
+          <p:nvPr/>
+        </p:nvSpPr>
+        <p:spPr>
+          <a:xfrm>
+            <a:off x="9308592" y="164592"/>
+            <a:ext cx="2331720" cy="384048"/>
+          </a:xfrm>
+          <a:prstGeom prst="roundRect">
+            <a:avLst/>
+          </a:prstGeom>
+          <a:solidFill>
+            <a:srgbClr val="123D2A"/>
+          </a:solidFill>
+          <a:ln>
+            <a:noFill/>
+          </a:ln>
+        </p:spPr>
+        <p:style>
+          <a:lnRef idx="1">
+            <a:schemeClr val="accent1"/>
+          </a:lnRef>
+          <a:fillRef idx="3">
+            <a:schemeClr val="accent1"/>
+          </a:fillRef>
+          <a:effectRef idx="2">
+            <a:schemeClr val="accent1"/>
+          </a:effectRef>
+          <a:fontRef idx="minor">
+            <a:schemeClr val="lt1"/>
+          </a:fontRef>
+        </p:style>
+        <p:txBody>
+          <a:bodyPr rtlCol="0" anchor="ctr"/>
+          <a:lstStyle/>
+          <a:p>
+            <a:pPr algn="ctr"/>
+          </a:p>
+        </p:txBody>
+      </p:sp>
+      <p:pic>
+        <p:nvPicPr>
+          <p:cNvPr id="15" name="Picture 14" descr="sangah-logo.png"/>
+          <p:cNvPicPr>
+            <a:picLocks noChangeAspect="1"/>
+          </p:cNvPicPr>
+          <p:nvPr/>
+        </p:nvPicPr>
+        <p:blipFill>
+          <a:blip r:embed="rId2"/>
+          <a:stretch>
+            <a:fillRect/>
+          </a:stretch>
+        </p:blipFill>
+        <p:spPr>
+          <a:xfrm>
+            <a:off x="9436608" y="256032"/>
+            <a:ext cx="2057400" cy="292608"/>
+          </a:xfrm>
+          <a:prstGeom prst="rect">
+            <a:avLst/>
+          </a:prstGeom>
+        </p:spPr>
+      </p:pic>
     </p:spTree>
   </p:cSld>
   <p:clrMapOvr>
@@ -6628,6 +7288,116 @@
           </a:p>
         </p:txBody>
       </p:sp>
+      <p:sp>
+        <p:nvSpPr>
+          <p:cNvPr id="8" name="Rectangle 7"/>
+          <p:cNvSpPr/>
+          <p:nvPr/>
+        </p:nvSpPr>
+        <p:spPr>
+          <a:xfrm>
+            <a:off x="566928" y="384048"/>
+            <a:ext cx="10744200" cy="22860"/>
+          </a:xfrm>
+          <a:prstGeom prst="rect">
+            <a:avLst/>
+          </a:prstGeom>
+          <a:solidFill>
+            <a:srgbClr val="0B8F55"/>
+          </a:solidFill>
+          <a:ln>
+            <a:noFill/>
+          </a:ln>
+        </p:spPr>
+        <p:style>
+          <a:lnRef idx="1">
+            <a:schemeClr val="accent1"/>
+          </a:lnRef>
+          <a:fillRef idx="3">
+            <a:schemeClr val="accent1"/>
+          </a:fillRef>
+          <a:effectRef idx="2">
+            <a:schemeClr val="accent1"/>
+          </a:effectRef>
+          <a:fontRef idx="minor">
+            <a:schemeClr val="lt1"/>
+          </a:fontRef>
+        </p:style>
+        <p:txBody>
+          <a:bodyPr rtlCol="0" anchor="ctr"/>
+          <a:lstStyle/>
+          <a:p>
+            <a:pPr algn="ctr"/>
+          </a:p>
+        </p:txBody>
+      </p:sp>
+      <p:sp>
+        <p:nvSpPr>
+          <p:cNvPr id="9" name="Rounded Rectangle 8"/>
+          <p:cNvSpPr/>
+          <p:nvPr/>
+        </p:nvSpPr>
+        <p:spPr>
+          <a:xfrm>
+            <a:off x="9308592" y="164592"/>
+            <a:ext cx="2331720" cy="384048"/>
+          </a:xfrm>
+          <a:prstGeom prst="roundRect">
+            <a:avLst/>
+          </a:prstGeom>
+          <a:solidFill>
+            <a:srgbClr val="123D2A"/>
+          </a:solidFill>
+          <a:ln>
+            <a:noFill/>
+          </a:ln>
+        </p:spPr>
+        <p:style>
+          <a:lnRef idx="1">
+            <a:schemeClr val="accent1"/>
+          </a:lnRef>
+          <a:fillRef idx="3">
+            <a:schemeClr val="accent1"/>
+          </a:fillRef>
+          <a:effectRef idx="2">
+            <a:schemeClr val="accent1"/>
+          </a:effectRef>
+          <a:fontRef idx="minor">
+            <a:schemeClr val="lt1"/>
+          </a:fontRef>
+        </p:style>
+        <p:txBody>
+          <a:bodyPr rtlCol="0" anchor="ctr"/>
+          <a:lstStyle/>
+          <a:p>
+            <a:pPr algn="ctr"/>
+          </a:p>
+        </p:txBody>
+      </p:sp>
+      <p:pic>
+        <p:nvPicPr>
+          <p:cNvPr id="10" name="Picture 9" descr="sangah-logo.png"/>
+          <p:cNvPicPr>
+            <a:picLocks noChangeAspect="1"/>
+          </p:cNvPicPr>
+          <p:nvPr/>
+        </p:nvPicPr>
+        <p:blipFill>
+          <a:blip r:embed="rId2"/>
+          <a:stretch>
+            <a:fillRect/>
+          </a:stretch>
+        </p:blipFill>
+        <p:spPr>
+          <a:xfrm>
+            <a:off x="9436608" y="256032"/>
+            <a:ext cx="2057400" cy="292608"/>
+          </a:xfrm>
+          <a:prstGeom prst="rect">
+            <a:avLst/>
+          </a:prstGeom>
+        </p:spPr>
+      </p:pic>
     </p:spTree>
   </p:cSld>
   <p:clrMapOvr>
@@ -7199,6 +7969,116 @@
           </a:p>
         </p:txBody>
       </p:sp>
+      <p:sp>
+        <p:nvSpPr>
+          <p:cNvPr id="15" name="Rectangle 14"/>
+          <p:cNvSpPr/>
+          <p:nvPr/>
+        </p:nvSpPr>
+        <p:spPr>
+          <a:xfrm>
+            <a:off x="566928" y="384048"/>
+            <a:ext cx="10744200" cy="22860"/>
+          </a:xfrm>
+          <a:prstGeom prst="rect">
+            <a:avLst/>
+          </a:prstGeom>
+          <a:solidFill>
+            <a:srgbClr val="0B8F55"/>
+          </a:solidFill>
+          <a:ln>
+            <a:noFill/>
+          </a:ln>
+        </p:spPr>
+        <p:style>
+          <a:lnRef idx="1">
+            <a:schemeClr val="accent1"/>
+          </a:lnRef>
+          <a:fillRef idx="3">
+            <a:schemeClr val="accent1"/>
+          </a:fillRef>
+          <a:effectRef idx="2">
+            <a:schemeClr val="accent1"/>
+          </a:effectRef>
+          <a:fontRef idx="minor">
+            <a:schemeClr val="lt1"/>
+          </a:fontRef>
+        </p:style>
+        <p:txBody>
+          <a:bodyPr rtlCol="0" anchor="ctr"/>
+          <a:lstStyle/>
+          <a:p>
+            <a:pPr algn="ctr"/>
+          </a:p>
+        </p:txBody>
+      </p:sp>
+      <p:sp>
+        <p:nvSpPr>
+          <p:cNvPr id="16" name="Rounded Rectangle 15"/>
+          <p:cNvSpPr/>
+          <p:nvPr/>
+        </p:nvSpPr>
+        <p:spPr>
+          <a:xfrm>
+            <a:off x="9308592" y="164592"/>
+            <a:ext cx="2331720" cy="384048"/>
+          </a:xfrm>
+          <a:prstGeom prst="roundRect">
+            <a:avLst/>
+          </a:prstGeom>
+          <a:solidFill>
+            <a:srgbClr val="123D2A"/>
+          </a:solidFill>
+          <a:ln>
+            <a:noFill/>
+          </a:ln>
+        </p:spPr>
+        <p:style>
+          <a:lnRef idx="1">
+            <a:schemeClr val="accent1"/>
+          </a:lnRef>
+          <a:fillRef idx="3">
+            <a:schemeClr val="accent1"/>
+          </a:fillRef>
+          <a:effectRef idx="2">
+            <a:schemeClr val="accent1"/>
+          </a:effectRef>
+          <a:fontRef idx="minor">
+            <a:schemeClr val="lt1"/>
+          </a:fontRef>
+        </p:style>
+        <p:txBody>
+          <a:bodyPr rtlCol="0" anchor="ctr"/>
+          <a:lstStyle/>
+          <a:p>
+            <a:pPr algn="ctr"/>
+          </a:p>
+        </p:txBody>
+      </p:sp>
+      <p:pic>
+        <p:nvPicPr>
+          <p:cNvPr id="17" name="Picture 16" descr="sangah-logo.png"/>
+          <p:cNvPicPr>
+            <a:picLocks noChangeAspect="1"/>
+          </p:cNvPicPr>
+          <p:nvPr/>
+        </p:nvPicPr>
+        <p:blipFill>
+          <a:blip r:embed="rId2"/>
+          <a:stretch>
+            <a:fillRect/>
+          </a:stretch>
+        </p:blipFill>
+        <p:spPr>
+          <a:xfrm>
+            <a:off x="9436608" y="256032"/>
+            <a:ext cx="2057400" cy="292608"/>
+          </a:xfrm>
+          <a:prstGeom prst="rect">
+            <a:avLst/>
+          </a:prstGeom>
+        </p:spPr>
+      </p:pic>
     </p:spTree>
   </p:cSld>
   <p:clrMapOvr>
@@ -7854,6 +8734,116 @@
           </a:p>
         </p:txBody>
       </p:sp>
+      <p:sp>
+        <p:nvSpPr>
+          <p:cNvPr id="16" name="Rectangle 15"/>
+          <p:cNvSpPr/>
+          <p:nvPr/>
+        </p:nvSpPr>
+        <p:spPr>
+          <a:xfrm>
+            <a:off x="566928" y="384048"/>
+            <a:ext cx="10744200" cy="22860"/>
+          </a:xfrm>
+          <a:prstGeom prst="rect">
+            <a:avLst/>
+          </a:prstGeom>
+          <a:solidFill>
+            <a:srgbClr val="0B8F55"/>
+          </a:solidFill>
+          <a:ln>
+            <a:noFill/>
+          </a:ln>
+        </p:spPr>
+        <p:style>
+          <a:lnRef idx="1">
+            <a:schemeClr val="accent1"/>
+          </a:lnRef>
+          <a:fillRef idx="3">
+            <a:schemeClr val="accent1"/>
+          </a:fillRef>
+          <a:effectRef idx="2">
+            <a:schemeClr val="accent1"/>
+          </a:effectRef>
+          <a:fontRef idx="minor">
+            <a:schemeClr val="lt1"/>
+          </a:fontRef>
+        </p:style>
+        <p:txBody>
+          <a:bodyPr rtlCol="0" anchor="ctr"/>
+          <a:lstStyle/>
+          <a:p>
+            <a:pPr algn="ctr"/>
+          </a:p>
+        </p:txBody>
+      </p:sp>
+      <p:sp>
+        <p:nvSpPr>
+          <p:cNvPr id="17" name="Rounded Rectangle 16"/>
+          <p:cNvSpPr/>
+          <p:nvPr/>
+        </p:nvSpPr>
+        <p:spPr>
+          <a:xfrm>
+            <a:off x="9308592" y="164592"/>
+            <a:ext cx="2331720" cy="384048"/>
+          </a:xfrm>
+          <a:prstGeom prst="roundRect">
+            <a:avLst/>
+          </a:prstGeom>
+          <a:solidFill>
+            <a:srgbClr val="123D2A"/>
+          </a:solidFill>
+          <a:ln>
+            <a:noFill/>
+          </a:ln>
+        </p:spPr>
+        <p:style>
+          <a:lnRef idx="1">
+            <a:schemeClr val="accent1"/>
+          </a:lnRef>
+          <a:fillRef idx="3">
+            <a:schemeClr val="accent1"/>
+          </a:fillRef>
+          <a:effectRef idx="2">
+            <a:schemeClr val="accent1"/>
+          </a:effectRef>
+          <a:fontRef idx="minor">
+            <a:schemeClr val="lt1"/>
+          </a:fontRef>
+        </p:style>
+        <p:txBody>
+          <a:bodyPr rtlCol="0" anchor="ctr"/>
+          <a:lstStyle/>
+          <a:p>
+            <a:pPr algn="ctr"/>
+          </a:p>
+        </p:txBody>
+      </p:sp>
+      <p:pic>
+        <p:nvPicPr>
+          <p:cNvPr id="18" name="Picture 17" descr="sangah-logo.png"/>
+          <p:cNvPicPr>
+            <a:picLocks noChangeAspect="1"/>
+          </p:cNvPicPr>
+          <p:nvPr/>
+        </p:nvPicPr>
+        <p:blipFill>
+          <a:blip r:embed="rId2"/>
+          <a:stretch>
+            <a:fillRect/>
+          </a:stretch>
+        </p:blipFill>
+        <p:spPr>
+          <a:xfrm>
+            <a:off x="9436608" y="256032"/>
+            <a:ext cx="2057400" cy="292608"/>
+          </a:xfrm>
+          <a:prstGeom prst="rect">
+            <a:avLst/>
+          </a:prstGeom>
+        </p:spPr>
+      </p:pic>
     </p:spTree>
   </p:cSld>
   <p:clrMapOvr>
@@ -8376,6 +9366,116 @@
           </a:p>
         </p:txBody>
       </p:sp>
+      <p:sp>
+        <p:nvSpPr>
+          <p:cNvPr id="14" name="Rectangle 13"/>
+          <p:cNvSpPr/>
+          <p:nvPr/>
+        </p:nvSpPr>
+        <p:spPr>
+          <a:xfrm>
+            <a:off x="566928" y="384048"/>
+            <a:ext cx="10744200" cy="22860"/>
+          </a:xfrm>
+          <a:prstGeom prst="rect">
+            <a:avLst/>
+          </a:prstGeom>
+          <a:solidFill>
+            <a:srgbClr val="0B8F55"/>
+          </a:solidFill>
+          <a:ln>
+            <a:noFill/>
+          </a:ln>
+        </p:spPr>
+        <p:style>
+          <a:lnRef idx="1">
+            <a:schemeClr val="accent1"/>
+          </a:lnRef>
+          <a:fillRef idx="3">
+            <a:schemeClr val="accent1"/>
+          </a:fillRef>
+          <a:effectRef idx="2">
+            <a:schemeClr val="accent1"/>
+          </a:effectRef>
+          <a:fontRef idx="minor">
+            <a:schemeClr val="lt1"/>
+          </a:fontRef>
+        </p:style>
+        <p:txBody>
+          <a:bodyPr rtlCol="0" anchor="ctr"/>
+          <a:lstStyle/>
+          <a:p>
+            <a:pPr algn="ctr"/>
+          </a:p>
+        </p:txBody>
+      </p:sp>
+      <p:sp>
+        <p:nvSpPr>
+          <p:cNvPr id="15" name="Rounded Rectangle 14"/>
+          <p:cNvSpPr/>
+          <p:nvPr/>
+        </p:nvSpPr>
+        <p:spPr>
+          <a:xfrm>
+            <a:off x="9308592" y="164592"/>
+            <a:ext cx="2331720" cy="384048"/>
+          </a:xfrm>
+          <a:prstGeom prst="roundRect">
+            <a:avLst/>
+          </a:prstGeom>
+          <a:solidFill>
+            <a:srgbClr val="123D2A"/>
+          </a:solidFill>
+          <a:ln>
+            <a:noFill/>
+          </a:ln>
+        </p:spPr>
+        <p:style>
+          <a:lnRef idx="1">
+            <a:schemeClr val="accent1"/>
+          </a:lnRef>
+          <a:fillRef idx="3">
+            <a:schemeClr val="accent1"/>
+          </a:fillRef>
+          <a:effectRef idx="2">
+            <a:schemeClr val="accent1"/>
+          </a:effectRef>
+          <a:fontRef idx="minor">
+            <a:schemeClr val="lt1"/>
+          </a:fontRef>
+        </p:style>
+        <p:txBody>
+          <a:bodyPr rtlCol="0" anchor="ctr"/>
+          <a:lstStyle/>
+          <a:p>
+            <a:pPr algn="ctr"/>
+          </a:p>
+        </p:txBody>
+      </p:sp>
+      <p:pic>
+        <p:nvPicPr>
+          <p:cNvPr id="16" name="Picture 15" descr="sangah-logo.png"/>
+          <p:cNvPicPr>
+            <a:picLocks noChangeAspect="1"/>
+          </p:cNvPicPr>
+          <p:nvPr/>
+        </p:nvPicPr>
+        <p:blipFill>
+          <a:blip r:embed="rId2"/>
+          <a:stretch>
+            <a:fillRect/>
+          </a:stretch>
+        </p:blipFill>
+        <p:spPr>
+          <a:xfrm>
+            <a:off x="9436608" y="256032"/>
+            <a:ext cx="2057400" cy="292608"/>
+          </a:xfrm>
+          <a:prstGeom prst="rect">
+            <a:avLst/>
+          </a:prstGeom>
+        </p:spPr>
+      </p:pic>
     </p:spTree>
   </p:cSld>
   <p:clrMapOvr>
@@ -8898,6 +9998,116 @@
           </a:p>
         </p:txBody>
       </p:sp>
+      <p:sp>
+        <p:nvSpPr>
+          <p:cNvPr id="14" name="Rectangle 13"/>
+          <p:cNvSpPr/>
+          <p:nvPr/>
+        </p:nvSpPr>
+        <p:spPr>
+          <a:xfrm>
+            <a:off x="566928" y="384048"/>
+            <a:ext cx="10744200" cy="22860"/>
+          </a:xfrm>
+          <a:prstGeom prst="rect">
+            <a:avLst/>
+          </a:prstGeom>
+          <a:solidFill>
+            <a:srgbClr val="0B8F55"/>
+          </a:solidFill>
+          <a:ln>
+            <a:noFill/>
+          </a:ln>
+        </p:spPr>
+        <p:style>
+          <a:lnRef idx="1">
+            <a:schemeClr val="accent1"/>
+          </a:lnRef>
+          <a:fillRef idx="3">
+            <a:schemeClr val="accent1"/>
+          </a:fillRef>
+          <a:effectRef idx="2">
+            <a:schemeClr val="accent1"/>
+          </a:effectRef>
+          <a:fontRef idx="minor">
+            <a:schemeClr val="lt1"/>
+          </a:fontRef>
+        </p:style>
+        <p:txBody>
+          <a:bodyPr rtlCol="0" anchor="ctr"/>
+          <a:lstStyle/>
+          <a:p>
+            <a:pPr algn="ctr"/>
+          </a:p>
+        </p:txBody>
+      </p:sp>
+      <p:sp>
+        <p:nvSpPr>
+          <p:cNvPr id="15" name="Rounded Rectangle 14"/>
+          <p:cNvSpPr/>
+          <p:nvPr/>
+        </p:nvSpPr>
+        <p:spPr>
+          <a:xfrm>
+            <a:off x="9308592" y="164592"/>
+            <a:ext cx="2331720" cy="384048"/>
+          </a:xfrm>
+          <a:prstGeom prst="roundRect">
+            <a:avLst/>
+          </a:prstGeom>
+          <a:solidFill>
+            <a:srgbClr val="123D2A"/>
+          </a:solidFill>
+          <a:ln>
+            <a:noFill/>
+          </a:ln>
+        </p:spPr>
+        <p:style>
+          <a:lnRef idx="1">
+            <a:schemeClr val="accent1"/>
+          </a:lnRef>
+          <a:fillRef idx="3">
+            <a:schemeClr val="accent1"/>
+          </a:fillRef>
+          <a:effectRef idx="2">
+            <a:schemeClr val="accent1"/>
+          </a:effectRef>
+          <a:fontRef idx="minor">
+            <a:schemeClr val="lt1"/>
+          </a:fontRef>
+        </p:style>
+        <p:txBody>
+          <a:bodyPr rtlCol="0" anchor="ctr"/>
+          <a:lstStyle/>
+          <a:p>
+            <a:pPr algn="ctr"/>
+          </a:p>
+        </p:txBody>
+      </p:sp>
+      <p:pic>
+        <p:nvPicPr>
+          <p:cNvPr id="16" name="Picture 15" descr="sangah-logo.png"/>
+          <p:cNvPicPr>
+            <a:picLocks noChangeAspect="1"/>
+          </p:cNvPicPr>
+          <p:nvPr/>
+        </p:nvPicPr>
+        <p:blipFill>
+          <a:blip r:embed="rId2"/>
+          <a:stretch>
+            <a:fillRect/>
+          </a:stretch>
+        </p:blipFill>
+        <p:spPr>
+          <a:xfrm>
+            <a:off x="9436608" y="256032"/>
+            <a:ext cx="2057400" cy="292608"/>
+          </a:xfrm>
+          <a:prstGeom prst="rect">
+            <a:avLst/>
+          </a:prstGeom>
+        </p:spPr>
+      </p:pic>
     </p:spTree>
   </p:cSld>
   <p:clrMapOvr>
@@ -9452,6 +10662,116 @@
           </a:p>
         </p:txBody>
       </p:sp>
+      <p:sp>
+        <p:nvSpPr>
+          <p:cNvPr id="8" name="Rectangle 7"/>
+          <p:cNvSpPr/>
+          <p:nvPr/>
+        </p:nvSpPr>
+        <p:spPr>
+          <a:xfrm>
+            <a:off x="566928" y="384048"/>
+            <a:ext cx="10744200" cy="22860"/>
+          </a:xfrm>
+          <a:prstGeom prst="rect">
+            <a:avLst/>
+          </a:prstGeom>
+          <a:solidFill>
+            <a:srgbClr val="0B8F55"/>
+          </a:solidFill>
+          <a:ln>
+            <a:noFill/>
+          </a:ln>
+        </p:spPr>
+        <p:style>
+          <a:lnRef idx="1">
+            <a:schemeClr val="accent1"/>
+          </a:lnRef>
+          <a:fillRef idx="3">
+            <a:schemeClr val="accent1"/>
+          </a:fillRef>
+          <a:effectRef idx="2">
+            <a:schemeClr val="accent1"/>
+          </a:effectRef>
+          <a:fontRef idx="minor">
+            <a:schemeClr val="lt1"/>
+          </a:fontRef>
+        </p:style>
+        <p:txBody>
+          <a:bodyPr rtlCol="0" anchor="ctr"/>
+          <a:lstStyle/>
+          <a:p>
+            <a:pPr algn="ctr"/>
+          </a:p>
+        </p:txBody>
+      </p:sp>
+      <p:sp>
+        <p:nvSpPr>
+          <p:cNvPr id="9" name="Rounded Rectangle 8"/>
+          <p:cNvSpPr/>
+          <p:nvPr/>
+        </p:nvSpPr>
+        <p:spPr>
+          <a:xfrm>
+            <a:off x="9308592" y="164592"/>
+            <a:ext cx="2331720" cy="384048"/>
+          </a:xfrm>
+          <a:prstGeom prst="roundRect">
+            <a:avLst/>
+          </a:prstGeom>
+          <a:solidFill>
+            <a:srgbClr val="123D2A"/>
+          </a:solidFill>
+          <a:ln>
+            <a:noFill/>
+          </a:ln>
+        </p:spPr>
+        <p:style>
+          <a:lnRef idx="1">
+            <a:schemeClr val="accent1"/>
+          </a:lnRef>
+          <a:fillRef idx="3">
+            <a:schemeClr val="accent1"/>
+          </a:fillRef>
+          <a:effectRef idx="2">
+            <a:schemeClr val="accent1"/>
+          </a:effectRef>
+          <a:fontRef idx="minor">
+            <a:schemeClr val="lt1"/>
+          </a:fontRef>
+        </p:style>
+        <p:txBody>
+          <a:bodyPr rtlCol="0" anchor="ctr"/>
+          <a:lstStyle/>
+          <a:p>
+            <a:pPr algn="ctr"/>
+          </a:p>
+        </p:txBody>
+      </p:sp>
+      <p:pic>
+        <p:nvPicPr>
+          <p:cNvPr id="10" name="Picture 9" descr="sangah-logo.png"/>
+          <p:cNvPicPr>
+            <a:picLocks noChangeAspect="1"/>
+          </p:cNvPicPr>
+          <p:nvPr/>
+        </p:nvPicPr>
+        <p:blipFill>
+          <a:blip r:embed="rId2"/>
+          <a:stretch>
+            <a:fillRect/>
+          </a:stretch>
+        </p:blipFill>
+        <p:spPr>
+          <a:xfrm>
+            <a:off x="9436608" y="256032"/>
+            <a:ext cx="2057400" cy="292608"/>
+          </a:xfrm>
+          <a:prstGeom prst="rect">
+            <a:avLst/>
+          </a:prstGeom>
+        </p:spPr>
+      </p:pic>
     </p:spTree>
   </p:cSld>
   <p:clrMapOvr>

</xml_diff>